<commit_message>
chore: update id-3b-lora Modelfile calibration, prototype deck, add eval set
Co-Authored-By: Claude Fable 5 <noreply@anthropic.com>
</commit_message>
<xml_diff>
--- a/Constrained Gödel-Agent Prototype.pptx
+++ b/Constrained Gödel-Agent Prototype.pptx
@@ -16,8 +16,8 @@
     <p:sldId id="287" r:id="rId10"/>
     <p:sldId id="288" r:id="rId11"/>
     <p:sldId id="289" r:id="rId12"/>
-    <p:sldId id="305" r:id="rId13"/>
-    <p:sldId id="304" r:id="rId14"/>
+    <p:sldId id="311" r:id="rId13"/>
+    <p:sldId id="315" r:id="rId14"/>
     <p:sldId id="295" r:id="rId15"/>
   </p:sldIdLst>
   <p:sldSz cx="12192000" cy="6858000"/>
@@ -5036,7 +5036,7 @@
                 </a:solidFill>
                 <a:latin typeface="Indosat Regular" pitchFamily="2" charset="77"/>
               </a:rPr>
-              <a:t>The team</a:t>
+              <a:t>The team — just two people</a:t>
             </a:r>
           </a:p>
         </p:txBody>
@@ -5346,7 +5346,7 @@
                   <a:srgbClr val="2E3047"/>
                 </a:solidFill>
               </a:rPr>
-              <a:t>Reuse an existing server + a repurposed / spare GPU — or a few on-demand cloud GPU hours · local LLM quantized to run on modest hardware</a:t>
+              <a:t>Reuse an existing server + an owned / repurposed GPU (no capital cost) — electricity only · local LLM quantized to run on modest hardware</a:t>
             </a:r>
           </a:p>
         </p:txBody>
@@ -5483,729 +5483,445 @@
                   <a:srgbClr val="2E3047"/>
                 </a:solidFill>
               </a:rPr>
-              <a:t>Reused servers, no dedicated cluster · LoRA fine-tune a small model on one owned or hourly-rented GPU · serve a quantized model on current hardware</a:t>
-            </a:r>
-          </a:p>
-        </p:txBody>
-      </p:sp>
-      <p:graphicFrame>
-        <p:nvGraphicFramePr>
-          <p:cNvPr id="6" name="Table 5">
-            <a:extLst>
-              <a:ext uri="{FF2B5EF4-FFF2-40B4-BE49-F238E27FC236}">
-                <a16:creationId xmlns:a16="http://schemas.microsoft.com/office/drawing/2014/main" id="{E7049CB7-0436-8E49-8F9C-907C48A85E04}"/>
-              </a:ext>
-            </a:extLst>
-          </p:cNvPr>
-          <p:cNvGraphicFramePr>
-            <a:graphicFrameLocks noGrp="1"/>
-          </p:cNvGraphicFramePr>
-          <p:nvPr>
-            <p:extLst>
-              <p:ext uri="{D42A27DB-BD31-4B8C-83A1-F6EECF244321}">
-                <p14:modId xmlns:p14="http://schemas.microsoft.com/office/powerpoint/2010/main" val="3589109596"/>
-              </p:ext>
-            </p:extLst>
-          </p:nvPr>
-        </p:nvGraphicFramePr>
-        <p:xfrm>
-          <a:off x="838200" y="2387600"/>
-          <a:ext cx="5105400" cy="3809997"/>
-        </p:xfrm>
-        <a:graphic>
-          <a:graphicData uri="http://schemas.openxmlformats.org/drawingml/2006/table">
-            <a:tbl>
-              <a:tblPr firstRow="1" bandRow="1">
-                <a:tableStyleId>{5C22544A-7EE6-4342-B048-85BDC9FD1C3A}</a:tableStyleId>
-              </a:tblPr>
-              <a:tblGrid>
-                <a:gridCol w="2997200">
-                  <a:extLst>
-                    <a:ext uri="{9D8B030D-6E8A-4147-A177-3AD203B41FA5}">
-                      <a16:colId xmlns:a16="http://schemas.microsoft.com/office/drawing/2014/main" val="2120598522"/>
-                    </a:ext>
-                  </a:extLst>
-                </a:gridCol>
-                <a:gridCol w="889000">
-                  <a:extLst>
-                    <a:ext uri="{9D8B030D-6E8A-4147-A177-3AD203B41FA5}">
-                      <a16:colId xmlns:a16="http://schemas.microsoft.com/office/drawing/2014/main" val="2590776917"/>
-                    </a:ext>
-                  </a:extLst>
-                </a:gridCol>
-                <a:gridCol w="1219200">
-                  <a:extLst>
-                    <a:ext uri="{9D8B030D-6E8A-4147-A177-3AD203B41FA5}">
-                      <a16:colId xmlns:a16="http://schemas.microsoft.com/office/drawing/2014/main" val="1932733799"/>
-                    </a:ext>
-                  </a:extLst>
-                </a:gridCol>
-              </a:tblGrid>
-              <a:tr h="423333">
-                <a:tc>
-                  <a:txBody>
-                    <a:bodyPr/>
-                    <a:lstStyle/>
-                    <a:p>
-                      <a:pPr algn="l"/>
-                      <a:r>
-                        <a:rPr lang="en-US" sz="1400" b="1">
-                          <a:solidFill>
-                            <a:srgbClr val="FFFFFF"/>
-                          </a:solidFill>
-                        </a:rPr>
-                        <a:t>Role</a:t>
-                      </a:r>
-                    </a:p>
-                  </a:txBody>
-                  <a:tcPr anchor="ctr">
-                    <a:solidFill>
-                      <a:srgbClr val="1B8A7E"/>
-                    </a:solidFill>
-                  </a:tcPr>
-                </a:tc>
-                <a:tc>
-                  <a:txBody>
-                    <a:bodyPr/>
-                    <a:lstStyle/>
-                    <a:p>
-                      <a:pPr algn="ctr"/>
-                      <a:r>
-                        <a:rPr lang="en-US" sz="1400" b="1">
-                          <a:solidFill>
-                            <a:srgbClr val="FFFFFF"/>
-                          </a:solidFill>
-                        </a:rPr>
-                        <a:t>FTE</a:t>
-                      </a:r>
-                    </a:p>
-                  </a:txBody>
-                  <a:tcPr anchor="ctr">
-                    <a:solidFill>
-                      <a:srgbClr val="1B8A7E"/>
-                    </a:solidFill>
-                  </a:tcPr>
-                </a:tc>
-                <a:tc>
-                  <a:txBody>
-                    <a:bodyPr/>
-                    <a:lstStyle/>
-                    <a:p>
-                      <a:pPr algn="ctr"/>
-                      <a:r>
-                        <a:rPr lang="en-US" sz="1400" b="1">
-                          <a:solidFill>
-                            <a:srgbClr val="FFFFFF"/>
-                          </a:solidFill>
-                        </a:rPr>
-                        <a:t>Source</a:t>
-                      </a:r>
-                    </a:p>
-                  </a:txBody>
-                  <a:tcPr anchor="ctr">
-                    <a:solidFill>
-                      <a:srgbClr val="1B8A7E"/>
-                    </a:solidFill>
-                  </a:tcPr>
-                </a:tc>
-                <a:extLst>
-                  <a:ext uri="{0D108BD9-81ED-4DB2-BD59-A6C34878D82A}">
-                    <a16:rowId xmlns:a16="http://schemas.microsoft.com/office/drawing/2014/main" val="4264248964"/>
-                  </a:ext>
-                </a:extLst>
-              </a:tr>
-              <a:tr h="423333">
-                <a:tc>
-                  <a:txBody>
-                    <a:bodyPr/>
-                    <a:lstStyle/>
-                    <a:p>
-                      <a:pPr algn="l"/>
-                      <a:r>
-                        <a:rPr lang="en-US" sz="1300">
-                          <a:solidFill>
-                            <a:srgbClr val="2E3047"/>
-                          </a:solidFill>
-                        </a:rPr>
-                        <a:t>ML / AI Engineer</a:t>
-                      </a:r>
-                    </a:p>
-                  </a:txBody>
-                  <a:tcPr anchor="ctr">
-                    <a:solidFill>
-                      <a:srgbClr val="FFFFFF"/>
-                    </a:solidFill>
-                  </a:tcPr>
-                </a:tc>
-                <a:tc>
-                  <a:txBody>
-                    <a:bodyPr/>
-                    <a:lstStyle/>
-                    <a:p>
-                      <a:pPr algn="r"/>
-                      <a:r>
-                        <a:rPr lang="en-US" sz="1300">
-                          <a:solidFill>
-                            <a:srgbClr val="2E3047"/>
-                          </a:solidFill>
-                        </a:rPr>
-                        <a:t>0.5</a:t>
-                      </a:r>
-                    </a:p>
-                  </a:txBody>
-                  <a:tcPr anchor="ctr">
-                    <a:solidFill>
-                      <a:srgbClr val="FFFFFF"/>
-                    </a:solidFill>
-                  </a:tcPr>
-                </a:tc>
-                <a:tc>
-                  <a:txBody>
-                    <a:bodyPr/>
-                    <a:lstStyle/>
-                    <a:p>
-                      <a:pPr algn="ctr"/>
-                      <a:r>
-                        <a:rPr lang="en-US" sz="1300">
-                          <a:solidFill>
-                            <a:srgbClr val="2E3047"/>
-                          </a:solidFill>
-                        </a:rPr>
-                        <a:t>Existing</a:t>
-                      </a:r>
-                    </a:p>
-                  </a:txBody>
-                  <a:tcPr anchor="ctr">
-                    <a:solidFill>
-                      <a:srgbClr val="FFFFFF"/>
-                    </a:solidFill>
-                  </a:tcPr>
-                </a:tc>
-                <a:extLst>
-                  <a:ext uri="{0D108BD9-81ED-4DB2-BD59-A6C34878D82A}">
-                    <a16:rowId xmlns:a16="http://schemas.microsoft.com/office/drawing/2014/main" val="639191210"/>
-                  </a:ext>
-                </a:extLst>
-              </a:tr>
-              <a:tr h="423333">
-                <a:tc>
-                  <a:txBody>
-                    <a:bodyPr/>
-                    <a:lstStyle/>
-                    <a:p>
-                      <a:pPr algn="l"/>
-                      <a:r>
-                        <a:rPr lang="en-US" sz="1300">
-                          <a:solidFill>
-                            <a:srgbClr val="2E3047"/>
-                          </a:solidFill>
-                        </a:rPr>
-                        <a:t>Platform / Backend Engineer</a:t>
-                      </a:r>
-                    </a:p>
-                  </a:txBody>
-                  <a:tcPr anchor="ctr">
-                    <a:solidFill>
-                      <a:srgbClr val="F3F3F8"/>
-                    </a:solidFill>
-                  </a:tcPr>
-                </a:tc>
-                <a:tc>
-                  <a:txBody>
-                    <a:bodyPr/>
-                    <a:lstStyle/>
-                    <a:p>
-                      <a:pPr algn="r"/>
-                      <a:r>
-                        <a:rPr lang="en-US" sz="1300">
-                          <a:solidFill>
-                            <a:srgbClr val="2E3047"/>
-                          </a:solidFill>
-                        </a:rPr>
-                        <a:t>0.5</a:t>
-                      </a:r>
-                    </a:p>
-                  </a:txBody>
-                  <a:tcPr anchor="ctr">
-                    <a:solidFill>
-                      <a:srgbClr val="F3F3F8"/>
-                    </a:solidFill>
-                  </a:tcPr>
-                </a:tc>
-                <a:tc>
-                  <a:txBody>
-                    <a:bodyPr/>
-                    <a:lstStyle/>
-                    <a:p>
-                      <a:pPr algn="ctr"/>
-                      <a:r>
-                        <a:rPr lang="en-US" sz="1300">
-                          <a:solidFill>
-                            <a:srgbClr val="2E3047"/>
-                          </a:solidFill>
-                        </a:rPr>
-                        <a:t>Existing</a:t>
-                      </a:r>
-                    </a:p>
-                  </a:txBody>
-                  <a:tcPr anchor="ctr">
-                    <a:solidFill>
-                      <a:srgbClr val="F3F3F8"/>
-                    </a:solidFill>
-                  </a:tcPr>
-                </a:tc>
-                <a:extLst>
-                  <a:ext uri="{0D108BD9-81ED-4DB2-BD59-A6C34878D82A}">
-                    <a16:rowId xmlns:a16="http://schemas.microsoft.com/office/drawing/2014/main" val="3145183919"/>
-                  </a:ext>
-                </a:extLst>
-              </a:tr>
-              <a:tr h="423333">
-                <a:tc>
-                  <a:txBody>
-                    <a:bodyPr/>
-                    <a:lstStyle/>
-                    <a:p>
-                      <a:pPr algn="l"/>
-                      <a:r>
-                        <a:rPr lang="en-US" sz="1300">
-                          <a:solidFill>
-                            <a:srgbClr val="2E3047"/>
-                          </a:solidFill>
-                        </a:rPr>
-                        <a:t>Domain &amp; Evaluation SME</a:t>
-                      </a:r>
-                    </a:p>
-                  </a:txBody>
-                  <a:tcPr anchor="ctr">
-                    <a:solidFill>
-                      <a:srgbClr val="FFFFFF"/>
-                    </a:solidFill>
-                  </a:tcPr>
-                </a:tc>
-                <a:tc>
-                  <a:txBody>
-                    <a:bodyPr/>
-                    <a:lstStyle/>
-                    <a:p>
-                      <a:pPr algn="r"/>
-                      <a:r>
-                        <a:rPr lang="en-US" sz="1300">
-                          <a:solidFill>
-                            <a:srgbClr val="2E3047"/>
-                          </a:solidFill>
-                        </a:rPr>
-                        <a:t>0.3</a:t>
-                      </a:r>
-                    </a:p>
-                  </a:txBody>
-                  <a:tcPr anchor="ctr">
-                    <a:solidFill>
-                      <a:srgbClr val="FFFFFF"/>
-                    </a:solidFill>
-                  </a:tcPr>
-                </a:tc>
-                <a:tc>
-                  <a:txBody>
-                    <a:bodyPr/>
-                    <a:lstStyle/>
-                    <a:p>
-                      <a:pPr algn="ctr"/>
-                      <a:r>
-                        <a:rPr lang="en-US" sz="1300">
-                          <a:solidFill>
-                            <a:srgbClr val="2E3047"/>
-                          </a:solidFill>
-                        </a:rPr>
-                        <a:t>Existing</a:t>
-                      </a:r>
-                    </a:p>
-                  </a:txBody>
-                  <a:tcPr anchor="ctr">
-                    <a:solidFill>
-                      <a:srgbClr val="FFFFFF"/>
-                    </a:solidFill>
-                  </a:tcPr>
-                </a:tc>
-                <a:extLst>
-                  <a:ext uri="{0D108BD9-81ED-4DB2-BD59-A6C34878D82A}">
-                    <a16:rowId xmlns:a16="http://schemas.microsoft.com/office/drawing/2014/main" val="531013509"/>
-                  </a:ext>
-                </a:extLst>
-              </a:tr>
-              <a:tr h="423333">
-                <a:tc>
-                  <a:txBody>
-                    <a:bodyPr/>
-                    <a:lstStyle/>
-                    <a:p>
-                      <a:pPr algn="l"/>
-                      <a:r>
-                        <a:rPr lang="en-US" sz="1300">
-                          <a:solidFill>
-                            <a:srgbClr val="2E3047"/>
-                          </a:solidFill>
-                        </a:rPr>
-                        <a:t>Fine-tuning / ML Research</a:t>
-                      </a:r>
-                    </a:p>
-                  </a:txBody>
-                  <a:tcPr anchor="ctr">
-                    <a:solidFill>
-                      <a:srgbClr val="F3F3F8"/>
-                    </a:solidFill>
-                  </a:tcPr>
-                </a:tc>
-                <a:tc>
-                  <a:txBody>
-                    <a:bodyPr/>
-                    <a:lstStyle/>
-                    <a:p>
-                      <a:pPr algn="r"/>
-                      <a:r>
-                        <a:rPr lang="en-US" sz="1300">
-                          <a:solidFill>
-                            <a:srgbClr val="2E3047"/>
-                          </a:solidFill>
-                        </a:rPr>
-                        <a:t>0.5</a:t>
-                      </a:r>
-                    </a:p>
-                  </a:txBody>
-                  <a:tcPr anchor="ctr">
-                    <a:solidFill>
-                      <a:srgbClr val="F3F3F8"/>
-                    </a:solidFill>
-                  </a:tcPr>
-                </a:tc>
-                <a:tc>
-                  <a:txBody>
-                    <a:bodyPr/>
-                    <a:lstStyle/>
-                    <a:p>
-                      <a:pPr algn="ctr"/>
-                      <a:r>
-                        <a:rPr lang="en-US" sz="1300">
-                          <a:solidFill>
-                            <a:srgbClr val="2E3047"/>
-                          </a:solidFill>
-                        </a:rPr>
-                        <a:t>Upskill</a:t>
-                      </a:r>
-                    </a:p>
-                  </a:txBody>
-                  <a:tcPr anchor="ctr">
-                    <a:solidFill>
-                      <a:srgbClr val="F3F3F8"/>
-                    </a:solidFill>
-                  </a:tcPr>
-                </a:tc>
-                <a:extLst>
-                  <a:ext uri="{0D108BD9-81ED-4DB2-BD59-A6C34878D82A}">
-                    <a16:rowId xmlns:a16="http://schemas.microsoft.com/office/drawing/2014/main" val="1793079858"/>
-                  </a:ext>
-                </a:extLst>
-              </a:tr>
-              <a:tr h="423333">
-                <a:tc>
-                  <a:txBody>
-                    <a:bodyPr/>
-                    <a:lstStyle/>
-                    <a:p>
-                      <a:pPr algn="l"/>
-                      <a:r>
-                        <a:rPr lang="en-US" sz="1300">
-                          <a:solidFill>
-                            <a:srgbClr val="2E3047"/>
-                          </a:solidFill>
-                        </a:rPr>
-                        <a:t>MLOps / Infrastructure</a:t>
-                      </a:r>
-                    </a:p>
-                  </a:txBody>
-                  <a:tcPr anchor="ctr">
-                    <a:solidFill>
-                      <a:srgbClr val="FFFFFF"/>
-                    </a:solidFill>
-                  </a:tcPr>
-                </a:tc>
-                <a:tc>
-                  <a:txBody>
-                    <a:bodyPr/>
-                    <a:lstStyle/>
-                    <a:p>
-                      <a:pPr algn="r"/>
-                      <a:r>
-                        <a:rPr lang="en-US" sz="1300">
-                          <a:solidFill>
-                            <a:srgbClr val="2E3047"/>
-                          </a:solidFill>
-                        </a:rPr>
-                        <a:t>0.3</a:t>
-                      </a:r>
-                    </a:p>
-                  </a:txBody>
-                  <a:tcPr anchor="ctr">
-                    <a:solidFill>
-                      <a:srgbClr val="FFFFFF"/>
-                    </a:solidFill>
-                  </a:tcPr>
-                </a:tc>
-                <a:tc>
-                  <a:txBody>
-                    <a:bodyPr/>
-                    <a:lstStyle/>
-                    <a:p>
-                      <a:pPr algn="ctr"/>
-                      <a:r>
-                        <a:rPr lang="en-US" sz="1300">
-                          <a:solidFill>
-                            <a:srgbClr val="2E3047"/>
-                          </a:solidFill>
-                        </a:rPr>
-                        <a:t>Existing</a:t>
-                      </a:r>
-                    </a:p>
-                  </a:txBody>
-                  <a:tcPr anchor="ctr">
-                    <a:solidFill>
-                      <a:srgbClr val="FFFFFF"/>
-                    </a:solidFill>
-                  </a:tcPr>
-                </a:tc>
-                <a:extLst>
-                  <a:ext uri="{0D108BD9-81ED-4DB2-BD59-A6C34878D82A}">
-                    <a16:rowId xmlns:a16="http://schemas.microsoft.com/office/drawing/2014/main" val="1148822974"/>
-                  </a:ext>
-                </a:extLst>
-              </a:tr>
-              <a:tr h="423333">
-                <a:tc>
-                  <a:txBody>
-                    <a:bodyPr/>
-                    <a:lstStyle/>
-                    <a:p>
-                      <a:pPr algn="l"/>
-                      <a:r>
-                        <a:rPr lang="en-US" sz="1300">
-                          <a:solidFill>
-                            <a:srgbClr val="2E3047"/>
-                          </a:solidFill>
-                        </a:rPr>
-                        <a:t>Data Engineer</a:t>
-                      </a:r>
-                    </a:p>
-                  </a:txBody>
-                  <a:tcPr anchor="ctr">
-                    <a:solidFill>
-                      <a:srgbClr val="F3F3F8"/>
-                    </a:solidFill>
-                  </a:tcPr>
-                </a:tc>
-                <a:tc>
-                  <a:txBody>
-                    <a:bodyPr/>
-                    <a:lstStyle/>
-                    <a:p>
-                      <a:pPr algn="r"/>
-                      <a:r>
-                        <a:rPr lang="en-US" sz="1300">
-                          <a:solidFill>
-                            <a:srgbClr val="2E3047"/>
-                          </a:solidFill>
-                        </a:rPr>
-                        <a:t>0.3</a:t>
-                      </a:r>
-                    </a:p>
-                  </a:txBody>
-                  <a:tcPr anchor="ctr">
-                    <a:solidFill>
-                      <a:srgbClr val="F3F3F8"/>
-                    </a:solidFill>
-                  </a:tcPr>
-                </a:tc>
-                <a:tc>
-                  <a:txBody>
-                    <a:bodyPr/>
-                    <a:lstStyle/>
-                    <a:p>
-                      <a:pPr algn="ctr"/>
-                      <a:r>
-                        <a:rPr lang="en-US" sz="1300">
-                          <a:solidFill>
-                            <a:srgbClr val="2E3047"/>
-                          </a:solidFill>
-                        </a:rPr>
-                        <a:t>Existing</a:t>
-                      </a:r>
-                    </a:p>
-                  </a:txBody>
-                  <a:tcPr anchor="ctr">
-                    <a:solidFill>
-                      <a:srgbClr val="F3F3F8"/>
-                    </a:solidFill>
-                  </a:tcPr>
-                </a:tc>
-                <a:extLst>
-                  <a:ext uri="{0D108BD9-81ED-4DB2-BD59-A6C34878D82A}">
-                    <a16:rowId xmlns:a16="http://schemas.microsoft.com/office/drawing/2014/main" val="4157380224"/>
-                  </a:ext>
-                </a:extLst>
-              </a:tr>
-              <a:tr h="423333">
-                <a:tc>
-                  <a:txBody>
-                    <a:bodyPr/>
-                    <a:lstStyle/>
-                    <a:p>
-                      <a:pPr algn="l"/>
-                      <a:r>
-                        <a:rPr lang="en-US" sz="1300">
-                          <a:solidFill>
-                            <a:srgbClr val="2E3047"/>
-                          </a:solidFill>
-                        </a:rPr>
-                        <a:t>Product / Project Lead</a:t>
-                      </a:r>
-                    </a:p>
-                  </a:txBody>
-                  <a:tcPr anchor="ctr">
-                    <a:solidFill>
-                      <a:srgbClr val="FFFFFF"/>
-                    </a:solidFill>
-                  </a:tcPr>
-                </a:tc>
-                <a:tc>
-                  <a:txBody>
-                    <a:bodyPr/>
-                    <a:lstStyle/>
-                    <a:p>
-                      <a:pPr algn="r"/>
-                      <a:r>
-                        <a:rPr lang="en-US" sz="1300">
-                          <a:solidFill>
-                            <a:srgbClr val="2E3047"/>
-                          </a:solidFill>
-                        </a:rPr>
-                        <a:t>0.2</a:t>
-                      </a:r>
-                    </a:p>
-                  </a:txBody>
-                  <a:tcPr anchor="ctr">
-                    <a:solidFill>
-                      <a:srgbClr val="FFFFFF"/>
-                    </a:solidFill>
-                  </a:tcPr>
-                </a:tc>
-                <a:tc>
-                  <a:txBody>
-                    <a:bodyPr/>
-                    <a:lstStyle/>
-                    <a:p>
-                      <a:pPr algn="ctr"/>
-                      <a:r>
-                        <a:rPr lang="en-US" sz="1300">
-                          <a:solidFill>
-                            <a:srgbClr val="2E3047"/>
-                          </a:solidFill>
-                        </a:rPr>
-                        <a:t>Existing</a:t>
-                      </a:r>
-                    </a:p>
-                  </a:txBody>
-                  <a:tcPr anchor="ctr">
-                    <a:solidFill>
-                      <a:srgbClr val="FFFFFF"/>
-                    </a:solidFill>
-                  </a:tcPr>
-                </a:tc>
-                <a:extLst>
-                  <a:ext uri="{0D108BD9-81ED-4DB2-BD59-A6C34878D82A}">
-                    <a16:rowId xmlns:a16="http://schemas.microsoft.com/office/drawing/2014/main" val="3333470696"/>
-                  </a:ext>
-                </a:extLst>
-              </a:tr>
-              <a:tr h="423333">
-                <a:tc>
-                  <a:txBody>
-                    <a:bodyPr/>
-                    <a:lstStyle/>
-                    <a:p>
-                      <a:pPr algn="l"/>
-                      <a:r>
-                        <a:rPr lang="en-US" sz="1300" b="1">
-                          <a:solidFill>
-                            <a:srgbClr val="16182B"/>
-                          </a:solidFill>
-                        </a:rPr>
-                        <a:t>Peak (FTE-equivalent)</a:t>
-                      </a:r>
-                    </a:p>
-                  </a:txBody>
-                  <a:tcPr anchor="ctr">
-                    <a:solidFill>
-                      <a:srgbClr val="E6F7F4"/>
-                    </a:solidFill>
-                  </a:tcPr>
-                </a:tc>
-                <a:tc>
-                  <a:txBody>
-                    <a:bodyPr/>
-                    <a:lstStyle/>
-                    <a:p>
-                      <a:pPr algn="r"/>
-                      <a:r>
-                        <a:rPr lang="en-US" sz="1300" b="1">
-                          <a:solidFill>
-                            <a:srgbClr val="16182B"/>
-                          </a:solidFill>
-                        </a:rPr>
-                        <a:t>≈2.6</a:t>
-                      </a:r>
-                    </a:p>
-                  </a:txBody>
-                  <a:tcPr anchor="ctr">
-                    <a:solidFill>
-                      <a:srgbClr val="E6F7F4"/>
-                    </a:solidFill>
-                  </a:tcPr>
-                </a:tc>
-                <a:tc>
-                  <a:txBody>
-                    <a:bodyPr/>
-                    <a:lstStyle/>
-                    <a:p>
-                      <a:pPr algn="ctr"/>
-                      <a:r>
-                        <a:rPr lang="en-US" sz="1300" b="1">
-                          <a:solidFill>
-                            <a:srgbClr val="16182B"/>
-                          </a:solidFill>
-                        </a:rPr>
-                        <a:t>Reallocated</a:t>
-                      </a:r>
-                    </a:p>
-                  </a:txBody>
-                  <a:tcPr anchor="ctr">
-                    <a:solidFill>
-                      <a:srgbClr val="E6F7F4"/>
-                    </a:solidFill>
-                  </a:tcPr>
-                </a:tc>
-                <a:extLst>
-                  <a:ext uri="{0D108BD9-81ED-4DB2-BD59-A6C34878D82A}">
-                    <a16:rowId xmlns:a16="http://schemas.microsoft.com/office/drawing/2014/main" val="2580377151"/>
-                  </a:ext>
-                </a:extLst>
-              </a:tr>
-            </a:tbl>
-          </a:graphicData>
-        </a:graphic>
-      </p:graphicFrame>
+              <a:t>Reused servers, no dedicated cluster · LoRA fine-tune on the owned GPU (electricity only) · serve a quantized model on current hardware</a:t>
+            </a:r>
+          </a:p>
+        </p:txBody>
+      </p:sp>
+      <p:sp>
+        <p:nvSpPr>
+          <p:cNvPr id="761" name="pc761"/>
+          <p:cNvSpPr/>
+          <p:nvPr/>
+        </p:nvSpPr>
+        <p:spPr>
+          <a:xfrm>
+            <a:off x="838200" y="2362200"/>
+            <a:ext cx="5105400" cy="1752600"/>
+          </a:xfrm>
+          <a:prstGeom prst="roundRect">
+            <a:avLst>
+              <a:gd name="adj" fmla="val 6000"/>
+            </a:avLst>
+          </a:prstGeom>
+          <a:solidFill>
+            <a:srgbClr val="FFFFFF"/>
+          </a:solidFill>
+          <a:ln w="12700">
+            <a:solidFill>
+              <a:srgbClr val="E2E2EA"/>
+            </a:solidFill>
+          </a:ln>
+        </p:spPr>
+        <p:txBody>
+          <a:bodyPr/>
+          <a:lstStyle/>
+          <a:p>
+            <a:endParaRPr/>
+          </a:p>
+        </p:txBody>
+      </p:sp>
+      <p:sp>
+        <p:nvSpPr>
+          <p:cNvPr id="762" name="stp762"/>
+          <p:cNvSpPr/>
+          <p:nvPr/>
+        </p:nvSpPr>
+        <p:spPr>
+          <a:xfrm>
+            <a:off x="838200" y="2362200"/>
+            <a:ext cx="114300" cy="1752600"/>
+          </a:xfrm>
+          <a:prstGeom prst="roundRect">
+            <a:avLst>
+              <a:gd name="adj" fmla="val 50000"/>
+            </a:avLst>
+          </a:prstGeom>
+          <a:solidFill>
+            <a:srgbClr val="24BDAD"/>
+          </a:solidFill>
+          <a:ln>
+            <a:noFill/>
+          </a:ln>
+        </p:spPr>
+        <p:txBody>
+          <a:bodyPr/>
+          <a:lstStyle/>
+          <a:p>
+            <a:endParaRPr/>
+          </a:p>
+        </p:txBody>
+      </p:sp>
+      <p:sp>
+        <p:nvSpPr>
+          <p:cNvPr id="763" name="tl763"/>
+          <p:cNvSpPr txBox="1"/>
+          <p:nvPr/>
+        </p:nvSpPr>
+        <p:spPr>
+          <a:xfrm>
+            <a:off x="1143000" y="2489200"/>
+            <a:ext cx="4572000" cy="330200"/>
+          </a:xfrm>
+          <a:prstGeom prst="rect">
+            <a:avLst/>
+          </a:prstGeom>
+          <a:noFill/>
+        </p:spPr>
+        <p:txBody>
+          <a:bodyPr wrap="square">
+            <a:normAutofit lnSpcReduction="10000"/>
+          </a:bodyPr>
+          <a:lstStyle/>
+          <a:p>
+            <a:pPr algn="l"/>
+            <a:r>
+              <a:rPr lang="en-US" sz="1700" b="1" dirty="0">
+                <a:solidFill>
+                  <a:srgbClr val="16182B"/>
+                </a:solidFill>
+              </a:rPr>
+              <a:t>You — Initiator &amp; Technical Lead</a:t>
+            </a:r>
+          </a:p>
+        </p:txBody>
+      </p:sp>
+      <p:sp>
+        <p:nvSpPr>
+          <p:cNvPr id="764" name="tl764"/>
+          <p:cNvSpPr txBox="1"/>
+          <p:nvPr/>
+        </p:nvSpPr>
+        <p:spPr>
+          <a:xfrm>
+            <a:off x="1143000" y="2844800"/>
+            <a:ext cx="4572000" cy="254000"/>
+          </a:xfrm>
+          <a:prstGeom prst="rect">
+            <a:avLst/>
+          </a:prstGeom>
+          <a:noFill/>
+        </p:spPr>
+        <p:txBody>
+          <a:bodyPr wrap="square">
+            <a:normAutofit fontScale="92500" lnSpcReduction="20000"/>
+          </a:bodyPr>
+          <a:lstStyle/>
+          <a:p>
+            <a:pPr algn="l"/>
+            <a:r>
+              <a:rPr lang="en-US" sz="1300" i="1" dirty="0">
+                <a:solidFill>
+                  <a:srgbClr val="1B8A7E"/>
+                </a:solidFill>
+              </a:rPr>
+              <a:t>Agent core, safety gate &amp; delivery lead</a:t>
+            </a:r>
+          </a:p>
+        </p:txBody>
+      </p:sp>
+      <p:sp>
+        <p:nvSpPr>
+          <p:cNvPr id="765" name="bl765"/>
+          <p:cNvSpPr txBox="1"/>
+          <p:nvPr/>
+        </p:nvSpPr>
+        <p:spPr>
+          <a:xfrm>
+            <a:off x="1143000" y="3175000"/>
+            <a:ext cx="4572000" cy="838200"/>
+          </a:xfrm>
+          <a:prstGeom prst="rect">
+            <a:avLst/>
+          </a:prstGeom>
+          <a:noFill/>
+        </p:spPr>
+        <p:txBody>
+          <a:bodyPr wrap="square">
+            <a:normAutofit/>
+          </a:bodyPr>
+          <a:lstStyle/>
+          <a:p>
+            <a:pPr marL="171450" indent="-171450">
+              <a:lnSpc>
+                <a:spcPts val="1800"/>
+              </a:lnSpc>
+              <a:spcAft>
+                <a:spcPts val="300"/>
+              </a:spcAft>
+              <a:buFont typeface="Arial"/>
+              <a:buChar char="•"/>
+            </a:pPr>
+            <a:r>
+              <a:rPr lang="en-US" sz="1400" dirty="0">
+                <a:solidFill>
+                  <a:srgbClr val="2E3047"/>
+                </a:solidFill>
+              </a:rPr>
+              <a:t>Agent core loop, safety gate &amp; architecture</a:t>
+            </a:r>
+          </a:p>
+          <a:p>
+            <a:pPr marL="171450" indent="-171450">
+              <a:lnSpc>
+                <a:spcPts val="1800"/>
+              </a:lnSpc>
+              <a:spcAft>
+                <a:spcPts val="300"/>
+              </a:spcAft>
+              <a:buFont typeface="Arial"/>
+              <a:buChar char="•"/>
+            </a:pPr>
+            <a:r>
+              <a:rPr lang="en-US" sz="1400" dirty="0">
+                <a:solidFill>
+                  <a:srgbClr val="2E3047"/>
+                </a:solidFill>
+              </a:rPr>
+              <a:t>Integration, roadmap &amp; stakeholder management</a:t>
+            </a:r>
+          </a:p>
+        </p:txBody>
+      </p:sp>
+      <p:sp>
+        <p:nvSpPr>
+          <p:cNvPr id="766" name="pc766"/>
+          <p:cNvSpPr/>
+          <p:nvPr/>
+        </p:nvSpPr>
+        <p:spPr>
+          <a:xfrm>
+            <a:off x="838200" y="4216400"/>
+            <a:ext cx="5105400" cy="2311400"/>
+          </a:xfrm>
+          <a:prstGeom prst="roundRect">
+            <a:avLst>
+              <a:gd name="adj" fmla="val 6000"/>
+            </a:avLst>
+          </a:prstGeom>
+          <a:solidFill>
+            <a:srgbClr val="FFFFFF"/>
+          </a:solidFill>
+          <a:ln w="12700">
+            <a:solidFill>
+              <a:srgbClr val="E2E2EA"/>
+            </a:solidFill>
+          </a:ln>
+        </p:spPr>
+        <p:txBody>
+          <a:bodyPr/>
+          <a:lstStyle/>
+          <a:p>
+            <a:endParaRPr/>
+          </a:p>
+        </p:txBody>
+      </p:sp>
+      <p:sp>
+        <p:nvSpPr>
+          <p:cNvPr id="767" name="stp767"/>
+          <p:cNvSpPr/>
+          <p:nvPr/>
+        </p:nvSpPr>
+        <p:spPr>
+          <a:xfrm>
+            <a:off x="838200" y="4216400"/>
+            <a:ext cx="114300" cy="2311400"/>
+          </a:xfrm>
+          <a:prstGeom prst="roundRect">
+            <a:avLst>
+              <a:gd name="adj" fmla="val 50000"/>
+            </a:avLst>
+          </a:prstGeom>
+          <a:solidFill>
+            <a:srgbClr val="EC008C"/>
+          </a:solidFill>
+          <a:ln>
+            <a:noFill/>
+          </a:ln>
+        </p:spPr>
+        <p:txBody>
+          <a:bodyPr/>
+          <a:lstStyle/>
+          <a:p>
+            <a:endParaRPr/>
+          </a:p>
+        </p:txBody>
+      </p:sp>
+      <p:sp>
+        <p:nvSpPr>
+          <p:cNvPr id="768" name="tl768"/>
+          <p:cNvSpPr txBox="1"/>
+          <p:nvPr/>
+        </p:nvSpPr>
+        <p:spPr>
+          <a:xfrm>
+            <a:off x="1143000" y="4343400"/>
+            <a:ext cx="4572000" cy="330200"/>
+          </a:xfrm>
+          <a:prstGeom prst="rect">
+            <a:avLst/>
+          </a:prstGeom>
+          <a:noFill/>
+        </p:spPr>
+        <p:txBody>
+          <a:bodyPr wrap="square">
+            <a:normAutofit lnSpcReduction="10000"/>
+          </a:bodyPr>
+          <a:lstStyle/>
+          <a:p>
+            <a:pPr algn="l"/>
+            <a:r>
+              <a:rPr lang="en-US" sz="1700" b="1" dirty="0">
+                <a:solidFill>
+                  <a:srgbClr val="16182B"/>
+                </a:solidFill>
+              </a:rPr>
+              <a:t>Pramadhanu Parwito</a:t>
+            </a:r>
+          </a:p>
+        </p:txBody>
+      </p:sp>
+      <p:sp>
+        <p:nvSpPr>
+          <p:cNvPr id="769" name="tl769"/>
+          <p:cNvSpPr txBox="1"/>
+          <p:nvPr/>
+        </p:nvSpPr>
+        <p:spPr>
+          <a:xfrm>
+            <a:off x="1143000" y="4699000"/>
+            <a:ext cx="4572000" cy="254000"/>
+          </a:xfrm>
+          <a:prstGeom prst="rect">
+            <a:avLst/>
+          </a:prstGeom>
+          <a:noFill/>
+        </p:spPr>
+        <p:txBody>
+          <a:bodyPr wrap="square">
+            <a:normAutofit fontScale="92500" lnSpcReduction="20000"/>
+          </a:bodyPr>
+          <a:lstStyle/>
+          <a:p>
+            <a:pPr algn="l"/>
+            <a:r>
+              <a:rPr lang="en-US" sz="1300" i="1" dirty="0">
+                <a:solidFill>
+                  <a:srgbClr val="EC008C"/>
+                </a:solidFill>
+              </a:rPr>
+              <a:t>Data &amp; AI Engineer</a:t>
+            </a:r>
+          </a:p>
+        </p:txBody>
+      </p:sp>
+      <p:sp>
+        <p:nvSpPr>
+          <p:cNvPr id="770" name="bl770"/>
+          <p:cNvSpPr txBox="1"/>
+          <p:nvPr/>
+        </p:nvSpPr>
+        <p:spPr>
+          <a:xfrm>
+            <a:off x="1143000" y="5029200"/>
+            <a:ext cx="4572000" cy="1422400"/>
+          </a:xfrm>
+          <a:prstGeom prst="rect">
+            <a:avLst/>
+          </a:prstGeom>
+          <a:noFill/>
+        </p:spPr>
+        <p:txBody>
+          <a:bodyPr wrap="square">
+            <a:normAutofit/>
+          </a:bodyPr>
+          <a:lstStyle/>
+          <a:p>
+            <a:pPr marL="171450" indent="-171450">
+              <a:lnSpc>
+                <a:spcPts val="1750"/>
+              </a:lnSpc>
+              <a:spcAft>
+                <a:spcPts val="300"/>
+              </a:spcAft>
+              <a:buFont typeface="Arial"/>
+              <a:buChar char="•"/>
+            </a:pPr>
+            <a:r>
+              <a:rPr lang="en-US" sz="1350" dirty="0">
+                <a:solidFill>
+                  <a:srgbClr val="2E3047"/>
+                </a:solidFill>
+              </a:rPr>
+              <a:t>Data &amp; evaluation pipelines — PySpark, MongoDB, Docker</a:t>
+            </a:r>
+          </a:p>
+          <a:p>
+            <a:pPr marL="171450" indent="-171450">
+              <a:lnSpc>
+                <a:spcPts val="1750"/>
+              </a:lnSpc>
+              <a:spcAft>
+                <a:spcPts val="300"/>
+              </a:spcAft>
+              <a:buFont typeface="Arial"/>
+              <a:buChar char="•"/>
+            </a:pPr>
+            <a:r>
+              <a:rPr lang="en-US" sz="1350" dirty="0">
+                <a:solidFill>
+                  <a:srgbClr val="2E3047"/>
+                </a:solidFill>
+              </a:rPr>
+              <a:t>LLM integration &amp; orchestration — Dify, Qwen, Gemini</a:t>
+            </a:r>
+          </a:p>
+          <a:p>
+            <a:pPr marL="171450" indent="-171450">
+              <a:lnSpc>
+                <a:spcPts val="1750"/>
+              </a:lnSpc>
+              <a:spcAft>
+                <a:spcPts val="300"/>
+              </a:spcAft>
+              <a:buFont typeface="Arial"/>
+              <a:buChar char="•"/>
+            </a:pPr>
+            <a:r>
+              <a:rPr lang="en-US" sz="1350" dirty="0">
+                <a:solidFill>
+                  <a:srgbClr val="2E3047"/>
+                </a:solidFill>
+              </a:rPr>
+              <a:t>Evaluation &amp; holdout scoring — Metabase, Tableau</a:t>
+            </a:r>
+          </a:p>
+          <a:p>
+            <a:pPr marL="171450" indent="-171450">
+              <a:lnSpc>
+                <a:spcPts val="1750"/>
+              </a:lnSpc>
+              <a:spcAft>
+                <a:spcPts val="300"/>
+              </a:spcAft>
+              <a:buFont typeface="Arial"/>
+              <a:buChar char="•"/>
+            </a:pPr>
+            <a:r>
+              <a:rPr lang="en-US" sz="1350" dirty="0">
+                <a:solidFill>
+                  <a:srgbClr val="2E3047"/>
+                </a:solidFill>
+              </a:rPr>
+              <a:t>Native Indonesian — code-switching domain expertise</a:t>
+            </a:r>
+          </a:p>
+        </p:txBody>
+      </p:sp>
     </p:spTree>
     <p:extLst>
       <p:ext uri="{BB962C8B-B14F-4D97-AF65-F5344CB8AC3E}">
-        <p14:creationId xmlns:p14="http://schemas.microsoft.com/office/powerpoint/2010/main" val="3314066011"/>
+        <p14:creationId xmlns:p14="http://schemas.microsoft.com/office/powerpoint/2010/main" val="1089809564"/>
       </p:ext>
     </p:extLst>
   </p:cSld>
@@ -6299,9 +6015,8 @@
                 <a:solidFill>
                   <a:srgbClr val="FFFFFF"/>
                 </a:solidFill>
-                <a:latin typeface="Indosat Regular" pitchFamily="2" charset="77"/>
-              </a:rPr>
-              <a:t>Year-1 incremental investment ≈ Rp 300–600 million</a:t>
+              </a:rPr>
+              <a:t>Year-1 investment ≈ Rp 45–70 million</a:t>
             </a:r>
           </a:p>
           <a:p>
@@ -6311,9 +6026,8 @@
                 <a:solidFill>
                   <a:srgbClr val="B8ECE6"/>
                 </a:solidFill>
-                <a:latin typeface="Indosat Regular" pitchFamily="2" charset="77"/>
-              </a:rPr>
-              <a:t>Reuse existing hardware  ·  rent GPU time by the hour only for short fine-tuning bursts  ·  no new cluster</a:t>
+              </a:rPr>
+              <a:t>One data/AI intern stipend + electricity  ·  hardware reused (Rp 0)  ·  initiator already on payroll</a:t>
             </a:r>
           </a:p>
         </p:txBody>
@@ -6336,7 +6050,7 @@
         </p:spPr>
         <p:txBody>
           <a:bodyPr wrap="square">
-            <a:normAutofit fontScale="92500" lnSpcReduction="10000"/>
+            <a:normAutofit fontScale="92500"/>
           </a:bodyPr>
           <a:lstStyle/>
           <a:p>
@@ -6344,11 +6058,10 @@
             <a:r>
               <a:rPr lang="en-US" sz="1400" i="1" dirty="0">
                 <a:solidFill>
-                  <a:srgbClr val="5A5A6E"/>
-                </a:solidFill>
-                <a:latin typeface="Indosat Regular" pitchFamily="2" charset="77"/>
-              </a:rPr>
-              <a:t>*Illustrative reuse-first planning estimates (IDR). Team = existing staff reallocated part-time (~2.5 FTE-equivalent), not new hires. Infrastructure reuses current servers and workstations; fine-tuning uses an owned or hourly-rented GPU — no dedicated cluster. To be validated with IT and HR.</a:t>
+                  <a:srgbClr val="4A4A5A"/>
+                </a:solidFill>
+              </a:rPr>
+              <a:t>*Internship model: data/AI intern stipend ≈ Rp 3–5 M/mo + transport/meal (~1.1×), ~12 months ≈ Rp 40–66 M — no full BPJS/THR; fits a current MS AI &amp; Data Science student. Initiator on payroll (Rp 0); hardware owned/reused; electricity ~Rp 1,500/kWh. Validate stipend with HR.</a:t>
             </a:r>
           </a:p>
         </p:txBody>
@@ -6358,7 +6071,7 @@
           <p:cNvPr id="5" name="Table 4">
             <a:extLst>
               <a:ext uri="{FF2B5EF4-FFF2-40B4-BE49-F238E27FC236}">
-                <a16:creationId xmlns:a16="http://schemas.microsoft.com/office/drawing/2014/main" id="{9825C1D8-B0C7-9A42-AB36-1D60AB02EED0}"/>
+                <a16:creationId xmlns:a16="http://schemas.microsoft.com/office/drawing/2014/main" id="{19F46E75-4322-5A45-BE2B-37391D7B2140}"/>
               </a:ext>
             </a:extLst>
           </p:cNvPr>
@@ -6368,8 +6081,8 @@
           <p:nvPr/>
         </p:nvGraphicFramePr>
         <p:xfrm>
-          <a:off x="838200" y="2159000"/>
-          <a:ext cx="10515600" cy="2159000"/>
+          <a:off x="838200" y="2133600"/>
+          <a:ext cx="10515600" cy="2286000"/>
         </p:xfrm>
         <a:graphic>
           <a:graphicData uri="http://schemas.openxmlformats.org/drawingml/2006/table">
@@ -6378,43 +6091,43 @@
                 <a:tableStyleId>{5C22544A-7EE6-4342-B048-85BDC9FD1C3A}</a:tableStyleId>
               </a:tblPr>
               <a:tblGrid>
-                <a:gridCol w="1905000">
+                <a:gridCol w="2032000">
                   <a:extLst>
                     <a:ext uri="{9D8B030D-6E8A-4147-A177-3AD203B41FA5}">
-                      <a16:colId xmlns:a16="http://schemas.microsoft.com/office/drawing/2014/main" val="2766411108"/>
+                      <a16:colId xmlns:a16="http://schemas.microsoft.com/office/drawing/2014/main" val="2848647757"/>
                     </a:ext>
                   </a:extLst>
                 </a:gridCol>
                 <a:gridCol w="1066800">
                   <a:extLst>
                     <a:ext uri="{9D8B030D-6E8A-4147-A177-3AD203B41FA5}">
-                      <a16:colId xmlns:a16="http://schemas.microsoft.com/office/drawing/2014/main" val="760556109"/>
+                      <a16:colId xmlns:a16="http://schemas.microsoft.com/office/drawing/2014/main" val="2519272146"/>
                     </a:ext>
                   </a:extLst>
                 </a:gridCol>
-                <a:gridCol w="1397000">
+                <a:gridCol w="1905000">
                   <a:extLst>
                     <a:ext uri="{9D8B030D-6E8A-4147-A177-3AD203B41FA5}">
-                      <a16:colId xmlns:a16="http://schemas.microsoft.com/office/drawing/2014/main" val="3218091391"/>
+                      <a16:colId xmlns:a16="http://schemas.microsoft.com/office/drawing/2014/main" val="1991869782"/>
                     </a:ext>
                   </a:extLst>
                 </a:gridCol>
-                <a:gridCol w="3505200">
+                <a:gridCol w="2870200">
                   <a:extLst>
                     <a:ext uri="{9D8B030D-6E8A-4147-A177-3AD203B41FA5}">
-                      <a16:colId xmlns:a16="http://schemas.microsoft.com/office/drawing/2014/main" val="2813755034"/>
+                      <a16:colId xmlns:a16="http://schemas.microsoft.com/office/drawing/2014/main" val="1119821357"/>
                     </a:ext>
                   </a:extLst>
                 </a:gridCol>
                 <a:gridCol w="2641600">
                   <a:extLst>
                     <a:ext uri="{9D8B030D-6E8A-4147-A177-3AD203B41FA5}">
-                      <a16:colId xmlns:a16="http://schemas.microsoft.com/office/drawing/2014/main" val="1054505564"/>
+                      <a16:colId xmlns:a16="http://schemas.microsoft.com/office/drawing/2014/main" val="1289623454"/>
                     </a:ext>
                   </a:extLst>
                 </a:gridCol>
               </a:tblGrid>
-              <a:tr h="539750">
+              <a:tr h="571500">
                 <a:tc>
                   <a:txBody>
                     <a:bodyPr/>
@@ -6442,7 +6155,7 @@
                     <a:bodyPr/>
                     <a:lstStyle/>
                     <a:p>
-                      <a:pPr algn="l"/>
+                      <a:pPr algn="ctr"/>
                       <a:r>
                         <a:rPr lang="en-US" sz="1400" b="1">
                           <a:solidFill>
@@ -6464,7 +6177,7 @@
                     <a:bodyPr/>
                     <a:lstStyle/>
                     <a:p>
-                      <a:pPr algn="l"/>
+                      <a:pPr algn="ctr"/>
                       <a:r>
                         <a:rPr lang="en-US" sz="1400" b="1">
                           <a:solidFill>
@@ -6486,14 +6199,14 @@
                     <a:bodyPr/>
                     <a:lstStyle/>
                     <a:p>
-                      <a:pPr algn="l"/>
+                      <a:pPr algn="ctr"/>
                       <a:r>
                         <a:rPr lang="en-US" sz="1400" b="1">
                           <a:solidFill>
                             <a:srgbClr val="FFFFFF"/>
                           </a:solidFill>
                         </a:rPr>
-                        <a:t>Infrastructure (reuse-first)</a:t>
+                        <a:t>Compute &amp; power</a:t>
                       </a:r>
                     </a:p>
                   </a:txBody>
@@ -6515,7 +6228,7 @@
                             <a:srgbClr val="FFFFFF"/>
                           </a:solidFill>
                         </a:rPr>
-                        <a:t>Investment (IDR)</a:t>
+                        <a:t>Power cost (IDR)</a:t>
                       </a:r>
                     </a:p>
                   </a:txBody>
@@ -6527,11 +6240,11 @@
                 </a:tc>
                 <a:extLst>
                   <a:ext uri="{0D108BD9-81ED-4DB2-BD59-A6C34878D82A}">
-                    <a16:rowId xmlns:a16="http://schemas.microsoft.com/office/drawing/2014/main" val="3852053177"/>
+                    <a16:rowId xmlns:a16="http://schemas.microsoft.com/office/drawing/2014/main" val="3086480716"/>
                   </a:ext>
                 </a:extLst>
               </a:tr>
-              <a:tr h="539750">
+              <a:tr h="571500">
                 <a:tc>
                   <a:txBody>
                     <a:bodyPr/>
@@ -6539,11 +6252,7 @@
                     <a:p>
                       <a:pPr algn="l"/>
                       <a:r>
-                        <a:rPr lang="en-US" sz="1300">
-                          <a:solidFill>
-                            <a:srgbClr val="2E3047"/>
-                          </a:solidFill>
-                        </a:rPr>
+                        <a:rPr lang="en-US" sz="1300"/>
                         <a:t>1 · Prototype (now)</a:t>
                       </a:r>
                     </a:p>
@@ -6561,11 +6270,7 @@
                     <a:p>
                       <a:pPr algn="l"/>
                       <a:r>
-                        <a:rPr lang="en-US" sz="1300">
-                          <a:solidFill>
-                            <a:srgbClr val="2E3047"/>
-                          </a:solidFill>
-                        </a:rPr>
+                        <a:rPr lang="en-US" sz="1300"/>
                         <a:t>0–1 mo</a:t>
                       </a:r>
                     </a:p>
@@ -6583,12 +6288,8 @@
                     <a:p>
                       <a:pPr algn="l"/>
                       <a:r>
-                        <a:rPr lang="en-US" sz="1300">
-                          <a:solidFill>
-                            <a:srgbClr val="2E3047"/>
-                          </a:solidFill>
-                        </a:rPr>
-                        <a:t>Existing staff</a:t>
+                        <a:rPr lang="en-US" sz="1300"/>
+                        <a:t>Initiator (on payroll)</a:t>
                       </a:r>
                     </a:p>
                   </a:txBody>
@@ -6605,12 +6306,8 @@
                     <a:p>
                       <a:pPr algn="l"/>
                       <a:r>
-                        <a:rPr lang="en-US" sz="1300">
-                          <a:solidFill>
-                            <a:srgbClr val="2E3047"/>
-                          </a:solidFill>
-                        </a:rPr>
-                        <a:t>Current laptops / workstations</a:t>
+                        <a:rPr lang="en-US" sz="1300"/>
+                        <a:t>Laptop — negligible</a:t>
                       </a:r>
                     </a:p>
                   </a:txBody>
@@ -6632,7 +6329,7 @@
                             <a:srgbClr val="16182B"/>
                           </a:solidFill>
                         </a:rPr>
-                        <a:t>Rp 0</a:t>
+                        <a:t>~ Rp 0</a:t>
                       </a:r>
                     </a:p>
                   </a:txBody>
@@ -6644,11 +6341,11 @@
                 </a:tc>
                 <a:extLst>
                   <a:ext uri="{0D108BD9-81ED-4DB2-BD59-A6C34878D82A}">
-                    <a16:rowId xmlns:a16="http://schemas.microsoft.com/office/drawing/2014/main" val="4056797827"/>
+                    <a16:rowId xmlns:a16="http://schemas.microsoft.com/office/drawing/2014/main" val="4009985300"/>
                   </a:ext>
                 </a:extLst>
               </a:tr>
-              <a:tr h="539750">
+              <a:tr h="571500">
                 <a:tc>
                   <a:txBody>
                     <a:bodyPr/>
@@ -6656,11 +6353,7 @@
                     <a:p>
                       <a:pPr algn="l"/>
                       <a:r>
-                        <a:rPr lang="en-US" sz="1300">
-                          <a:solidFill>
-                            <a:srgbClr val="2E3047"/>
-                          </a:solidFill>
-                        </a:rPr>
+                        <a:rPr lang="en-US" sz="1300"/>
                         <a:t>2 · Pilot</a:t>
                       </a:r>
                     </a:p>
@@ -6678,11 +6371,7 @@
                     <a:p>
                       <a:pPr algn="l"/>
                       <a:r>
-                        <a:rPr lang="en-US" sz="1300">
-                          <a:solidFill>
-                            <a:srgbClr val="2E3047"/>
-                          </a:solidFill>
-                        </a:rPr>
+                        <a:rPr lang="en-US" sz="1300"/>
                         <a:t>3–4 mo</a:t>
                       </a:r>
                     </a:p>
@@ -6700,12 +6389,8 @@
                     <a:p>
                       <a:pPr algn="l"/>
                       <a:r>
-                        <a:rPr lang="en-US" sz="1300">
-                          <a:solidFill>
-                            <a:srgbClr val="2E3047"/>
-                          </a:solidFill>
-                        </a:rPr>
-                        <a:t>≈1.5 FTE*</a:t>
+                        <a:rPr lang="en-US" sz="1300"/>
+                        <a:t>+ 1 data/AI intern</a:t>
                       </a:r>
                     </a:p>
                   </a:txBody>
@@ -6722,12 +6407,8 @@
                     <a:p>
                       <a:pPr algn="l"/>
                       <a:r>
-                        <a:rPr lang="en-US" sz="1300">
-                          <a:solidFill>
-                            <a:srgbClr val="2E3047"/>
-                          </a:solidFill>
-                        </a:rPr>
-                        <a:t>Existing server + repurposed GPU / cloud hours</a:t>
+                        <a:rPr lang="en-US" sz="1300"/>
+                        <a:t>Owned GPU · ~0.5 kW · electricity</a:t>
                       </a:r>
                     </a:p>
                   </a:txBody>
@@ -6749,7 +6430,7 @@
                             <a:srgbClr val="16182B"/>
                           </a:solidFill>
                         </a:rPr>
-                        <a:t>Rp 50–150 M</a:t>
+                        <a:t>~ Rp 0.5 M</a:t>
                       </a:r>
                     </a:p>
                   </a:txBody>
@@ -6761,11 +6442,11 @@
                 </a:tc>
                 <a:extLst>
                   <a:ext uri="{0D108BD9-81ED-4DB2-BD59-A6C34878D82A}">
-                    <a16:rowId xmlns:a16="http://schemas.microsoft.com/office/drawing/2014/main" val="3695322824"/>
+                    <a16:rowId xmlns:a16="http://schemas.microsoft.com/office/drawing/2014/main" val="935680431"/>
                   </a:ext>
                 </a:extLst>
               </a:tr>
-              <a:tr h="539750">
+              <a:tr h="571500">
                 <a:tc>
                   <a:txBody>
                     <a:bodyPr/>
@@ -6773,11 +6454,7 @@
                     <a:p>
                       <a:pPr algn="l"/>
                       <a:r>
-                        <a:rPr lang="en-US" sz="1300">
-                          <a:solidFill>
-                            <a:srgbClr val="2E3047"/>
-                          </a:solidFill>
-                        </a:rPr>
+                        <a:rPr lang="en-US" sz="1300"/>
                         <a:t>3 · Production &amp; SLM</a:t>
                       </a:r>
                     </a:p>
@@ -6795,11 +6472,7 @@
                     <a:p>
                       <a:pPr algn="l"/>
                       <a:r>
-                        <a:rPr lang="en-US" sz="1300">
-                          <a:solidFill>
-                            <a:srgbClr val="2E3047"/>
-                          </a:solidFill>
-                        </a:rPr>
+                        <a:rPr lang="en-US" sz="1300"/>
                         <a:t>6–12 mo</a:t>
                       </a:r>
                     </a:p>
@@ -6817,12 +6490,8 @@
                     <a:p>
                       <a:pPr algn="l"/>
                       <a:r>
-                        <a:rPr lang="en-US" sz="1300">
-                          <a:solidFill>
-                            <a:srgbClr val="2E3047"/>
-                          </a:solidFill>
-                        </a:rPr>
-                        <a:t>≈2.5 FTE*</a:t>
+                        <a:rPr lang="en-US" sz="1300"/>
+                        <a:t>Initiator + 1 intern</a:t>
                       </a:r>
                     </a:p>
                   </a:txBody>
@@ -6839,12 +6508,8 @@
                     <a:p>
                       <a:pPr algn="l"/>
                       <a:r>
-                        <a:rPr lang="en-US" sz="1300">
-                          <a:solidFill>
-                            <a:srgbClr val="2E3047"/>
-                          </a:solidFill>
-                        </a:rPr>
-                        <a:t>Reused servers; LoRA on one GPU (owned or rented)</a:t>
+                        <a:rPr lang="en-US" sz="1300"/>
+                        <a:t>Owned GPU · bursts + serving</a:t>
                       </a:r>
                     </a:p>
                   </a:txBody>
@@ -6866,7 +6531,7 @@
                             <a:srgbClr val="16182B"/>
                           </a:solidFill>
                         </a:rPr>
-                        <a:t>Rp 200–400 M</a:t>
+                        <a:t>~ Rp 3–5 M</a:t>
                       </a:r>
                     </a:p>
                   </a:txBody>
@@ -6878,7 +6543,7 @@
                 </a:tc>
                 <a:extLst>
                   <a:ext uri="{0D108BD9-81ED-4DB2-BD59-A6C34878D82A}">
-                    <a16:rowId xmlns:a16="http://schemas.microsoft.com/office/drawing/2014/main" val="2718405358"/>
+                    <a16:rowId xmlns:a16="http://schemas.microsoft.com/office/drawing/2014/main" val="3885691734"/>
                   </a:ext>
                 </a:extLst>
               </a:tr>
@@ -6889,7 +6554,7 @@
     </p:spTree>
     <p:extLst>
       <p:ext uri="{BB962C8B-B14F-4D97-AF65-F5344CB8AC3E}">
-        <p14:creationId xmlns:p14="http://schemas.microsoft.com/office/powerpoint/2010/main" val="1481908449"/>
+        <p14:creationId xmlns:p14="http://schemas.microsoft.com/office/powerpoint/2010/main" val="2408203289"/>
       </p:ext>
     </p:extLst>
   </p:cSld>

</xml_diff>